<commit_message>
Added general scheme of software part of the our Diagnostics System into presentation file
</commit_message>
<xml_diff>
--- a/docs/AI based Vibroacoustic Diagnostics and Monitoring System.pptx
+++ b/docs/AI based Vibroacoustic Diagnostics and Monitoring System.pptx
@@ -9,8 +9,9 @@
     <p:sldId id="257" r:id="rId3"/>
     <p:sldId id="263" r:id="rId4"/>
     <p:sldId id="264" r:id="rId5"/>
-    <p:sldId id="258" r:id="rId6"/>
-    <p:sldId id="259" r:id="rId7"/>
+    <p:sldId id="265" r:id="rId6"/>
+    <p:sldId id="258" r:id="rId7"/>
+    <p:sldId id="259" r:id="rId8"/>
   </p:sldIdLst>
   <p:sldSz cx="9144000" cy="6858000" type="screen4x3"/>
   <p:notesSz cx="6858000" cy="9144000"/>
@@ -293,7 +294,7 @@
           <a:p>
             <a:fld id="{238961C7-9CE4-4D41-8170-7739EAE7BA18}" type="datetimeFigureOut">
               <a:rPr lang="ru-RU" smtClean="0"/>
-              <a:t>30.04.2026</a:t>
+              <a:t>04.05.2026</a:t>
             </a:fld>
             <a:endParaRPr lang="ru-RU"/>
           </a:p>
@@ -463,7 +464,7 @@
           <a:p>
             <a:fld id="{238961C7-9CE4-4D41-8170-7739EAE7BA18}" type="datetimeFigureOut">
               <a:rPr lang="ru-RU" smtClean="0"/>
-              <a:t>30.04.2026</a:t>
+              <a:t>04.05.2026</a:t>
             </a:fld>
             <a:endParaRPr lang="ru-RU"/>
           </a:p>
@@ -643,7 +644,7 @@
           <a:p>
             <a:fld id="{238961C7-9CE4-4D41-8170-7739EAE7BA18}" type="datetimeFigureOut">
               <a:rPr lang="ru-RU" smtClean="0"/>
-              <a:t>30.04.2026</a:t>
+              <a:t>04.05.2026</a:t>
             </a:fld>
             <a:endParaRPr lang="ru-RU"/>
           </a:p>
@@ -813,7 +814,7 @@
           <a:p>
             <a:fld id="{238961C7-9CE4-4D41-8170-7739EAE7BA18}" type="datetimeFigureOut">
               <a:rPr lang="ru-RU" smtClean="0"/>
-              <a:t>30.04.2026</a:t>
+              <a:t>04.05.2026</a:t>
             </a:fld>
             <a:endParaRPr lang="ru-RU"/>
           </a:p>
@@ -1059,7 +1060,7 @@
           <a:p>
             <a:fld id="{238961C7-9CE4-4D41-8170-7739EAE7BA18}" type="datetimeFigureOut">
               <a:rPr lang="ru-RU" smtClean="0"/>
-              <a:t>30.04.2026</a:t>
+              <a:t>04.05.2026</a:t>
             </a:fld>
             <a:endParaRPr lang="ru-RU"/>
           </a:p>
@@ -1347,7 +1348,7 @@
           <a:p>
             <a:fld id="{238961C7-9CE4-4D41-8170-7739EAE7BA18}" type="datetimeFigureOut">
               <a:rPr lang="ru-RU" smtClean="0"/>
-              <a:t>30.04.2026</a:t>
+              <a:t>04.05.2026</a:t>
             </a:fld>
             <a:endParaRPr lang="ru-RU"/>
           </a:p>
@@ -1769,7 +1770,7 @@
           <a:p>
             <a:fld id="{238961C7-9CE4-4D41-8170-7739EAE7BA18}" type="datetimeFigureOut">
               <a:rPr lang="ru-RU" smtClean="0"/>
-              <a:t>30.04.2026</a:t>
+              <a:t>04.05.2026</a:t>
             </a:fld>
             <a:endParaRPr lang="ru-RU"/>
           </a:p>
@@ -1887,7 +1888,7 @@
           <a:p>
             <a:fld id="{238961C7-9CE4-4D41-8170-7739EAE7BA18}" type="datetimeFigureOut">
               <a:rPr lang="ru-RU" smtClean="0"/>
-              <a:t>30.04.2026</a:t>
+              <a:t>04.05.2026</a:t>
             </a:fld>
             <a:endParaRPr lang="ru-RU"/>
           </a:p>
@@ -1982,7 +1983,7 @@
           <a:p>
             <a:fld id="{238961C7-9CE4-4D41-8170-7739EAE7BA18}" type="datetimeFigureOut">
               <a:rPr lang="ru-RU" smtClean="0"/>
-              <a:t>30.04.2026</a:t>
+              <a:t>04.05.2026</a:t>
             </a:fld>
             <a:endParaRPr lang="ru-RU"/>
           </a:p>
@@ -2259,7 +2260,7 @@
           <a:p>
             <a:fld id="{238961C7-9CE4-4D41-8170-7739EAE7BA18}" type="datetimeFigureOut">
               <a:rPr lang="ru-RU" smtClean="0"/>
-              <a:t>30.04.2026</a:t>
+              <a:t>04.05.2026</a:t>
             </a:fld>
             <a:endParaRPr lang="ru-RU"/>
           </a:p>
@@ -2512,7 +2513,7 @@
           <a:p>
             <a:fld id="{238961C7-9CE4-4D41-8170-7739EAE7BA18}" type="datetimeFigureOut">
               <a:rPr lang="ru-RU" smtClean="0"/>
-              <a:t>30.04.2026</a:t>
+              <a:t>04.05.2026</a:t>
             </a:fld>
             <a:endParaRPr lang="ru-RU"/>
           </a:p>
@@ -2725,7 +2726,7 @@
           <a:p>
             <a:fld id="{238961C7-9CE4-4D41-8170-7739EAE7BA18}" type="datetimeFigureOut">
               <a:rPr lang="ru-RU" smtClean="0"/>
-              <a:t>30.04.2026</a:t>
+              <a:t>04.05.2026</a:t>
             </a:fld>
             <a:endParaRPr lang="ru-RU"/>
           </a:p>
@@ -3132,11 +3133,7 @@
             </a:r>
             <a:r>
               <a:rPr lang="en-US" dirty="0" smtClean="0"/>
-              <a:t> </a:t>
-            </a:r>
-            <a:r>
-              <a:rPr lang="en-US" dirty="0" smtClean="0"/>
-              <a:t>Machinery State Diagnostics and Monitoring </a:t>
+              <a:t> Machinery State Diagnostics and Monitoring </a:t>
             </a:r>
             <a:r>
               <a:rPr lang="en-US" dirty="0"/>
@@ -4385,7 +4382,23 @@
           <a:p>
             <a:r>
               <a:rPr lang="en-US" sz="2400" dirty="0"/>
-              <a:t>Block Diagram of the Software part</a:t>
+              <a:t>Block Diagram </a:t>
+            </a:r>
+            <a:r>
+              <a:rPr lang="en-US" sz="2400" dirty="0" smtClean="0"/>
+              <a:t>of </a:t>
+            </a:r>
+            <a:r>
+              <a:rPr lang="en-US" sz="2400" dirty="0" smtClean="0"/>
+              <a:t>the </a:t>
+            </a:r>
+            <a:r>
+              <a:rPr lang="en-US" sz="2400" dirty="0"/>
+              <a:t>main piece of Software </a:t>
+            </a:r>
+            <a:r>
+              <a:rPr lang="en-US" sz="2400" dirty="0"/>
+              <a:t>part</a:t>
             </a:r>
             <a:br>
               <a:rPr lang="en-US" sz="2400" dirty="0"/>
@@ -6382,7 +6395,15 @@
           <a:p>
             <a:r>
               <a:rPr lang="en-US" sz="2400" dirty="0"/>
-              <a:t>Block Diagram of the Software part</a:t>
+              <a:t>Block Diagram of the </a:t>
+            </a:r>
+            <a:r>
+              <a:rPr lang="en-US" sz="2400" dirty="0" smtClean="0"/>
+              <a:t>main piece of Software </a:t>
+            </a:r>
+            <a:r>
+              <a:rPr lang="en-US" sz="2400" dirty="0"/>
+              <a:t>part</a:t>
             </a:r>
             <a:br>
               <a:rPr lang="en-US" sz="2400" dirty="0"/>
@@ -8824,6 +8845,1476 @@
         </p:nvSpPr>
         <p:spPr>
           <a:xfrm>
+            <a:off x="421196" y="44624"/>
+            <a:ext cx="8229600" cy="1080120"/>
+          </a:xfrm>
+        </p:spPr>
+        <p:txBody>
+          <a:bodyPr>
+            <a:normAutofit/>
+          </a:bodyPr>
+          <a:lstStyle/>
+          <a:p>
+            <a:r>
+              <a:rPr lang="en-US" sz="2400" dirty="0"/>
+              <a:t>Block Diagram of </a:t>
+            </a:r>
+            <a:r>
+              <a:rPr lang="en-US" sz="2400" dirty="0" smtClean="0"/>
+              <a:t>Software </a:t>
+            </a:r>
+            <a:r>
+              <a:rPr lang="en-US" sz="2400" dirty="0"/>
+              <a:t>part</a:t>
+            </a:r>
+            <a:br>
+              <a:rPr lang="en-US" sz="2400" dirty="0"/>
+            </a:br>
+            <a:r>
+              <a:rPr lang="en-US" sz="2400" dirty="0"/>
+              <a:t>of the System </a:t>
+            </a:r>
+            <a:r>
+              <a:rPr lang="en-US" sz="2400" dirty="0" smtClean="0"/>
+              <a:t>(General Scheme)</a:t>
+            </a:r>
+            <a:endParaRPr lang="ru-RU" sz="2400" dirty="0"/>
+          </a:p>
+        </p:txBody>
+      </p:sp>
+      <p:sp>
+        <p:nvSpPr>
+          <p:cNvPr id="9" name="Прямоугольник 8"/>
+          <p:cNvSpPr/>
+          <p:nvPr/>
+        </p:nvSpPr>
+        <p:spPr>
+          <a:xfrm>
+            <a:off x="611560" y="1196752"/>
+            <a:ext cx="7632848" cy="5472608"/>
+          </a:xfrm>
+          <a:prstGeom prst="rect">
+            <a:avLst/>
+          </a:prstGeom>
+          <a:noFill/>
+          <a:ln w="25400">
+            <a:solidFill>
+              <a:schemeClr val="tx2"/>
+            </a:solidFill>
+            <a:prstDash val="dashDot"/>
+          </a:ln>
+        </p:spPr>
+        <p:style>
+          <a:lnRef idx="2">
+            <a:schemeClr val="accent1">
+              <a:shade val="50000"/>
+            </a:schemeClr>
+          </a:lnRef>
+          <a:fillRef idx="1">
+            <a:schemeClr val="accent1"/>
+          </a:fillRef>
+          <a:effectRef idx="0">
+            <a:schemeClr val="accent1"/>
+          </a:effectRef>
+          <a:fontRef idx="minor">
+            <a:schemeClr val="lt1"/>
+          </a:fontRef>
+        </p:style>
+        <p:txBody>
+          <a:bodyPr rtlCol="0" anchor="ctr"/>
+          <a:lstStyle/>
+          <a:p>
+            <a:pPr algn="ctr"/>
+            <a:endParaRPr lang="ru-RU" dirty="0">
+              <a:solidFill>
+                <a:schemeClr val="tx1"/>
+              </a:solidFill>
+            </a:endParaRPr>
+          </a:p>
+        </p:txBody>
+      </p:sp>
+      <p:sp>
+        <p:nvSpPr>
+          <p:cNvPr id="23" name="Прямоугольник 22"/>
+          <p:cNvSpPr/>
+          <p:nvPr/>
+        </p:nvSpPr>
+        <p:spPr>
+          <a:xfrm>
+            <a:off x="1835696" y="4437112"/>
+            <a:ext cx="1368152" cy="864096"/>
+          </a:xfrm>
+          <a:prstGeom prst="rect">
+            <a:avLst/>
+          </a:prstGeom>
+          <a:noFill/>
+          <a:ln>
+            <a:prstDash val="sysDot"/>
+          </a:ln>
+        </p:spPr>
+        <p:style>
+          <a:lnRef idx="2">
+            <a:schemeClr val="accent1">
+              <a:shade val="50000"/>
+            </a:schemeClr>
+          </a:lnRef>
+          <a:fillRef idx="1">
+            <a:schemeClr val="accent1"/>
+          </a:fillRef>
+          <a:effectRef idx="0">
+            <a:schemeClr val="accent1"/>
+          </a:effectRef>
+          <a:fontRef idx="minor">
+            <a:schemeClr val="lt1"/>
+          </a:fontRef>
+        </p:style>
+        <p:txBody>
+          <a:bodyPr rtlCol="0" anchor="ctr"/>
+          <a:lstStyle/>
+          <a:p>
+            <a:pPr algn="ctr"/>
+            <a:endParaRPr lang="ru-RU"/>
+          </a:p>
+        </p:txBody>
+      </p:sp>
+      <p:sp>
+        <p:nvSpPr>
+          <p:cNvPr id="42" name="Прямоугольник 41"/>
+          <p:cNvSpPr/>
+          <p:nvPr/>
+        </p:nvSpPr>
+        <p:spPr>
+          <a:xfrm>
+            <a:off x="4283968" y="3284984"/>
+            <a:ext cx="1368152" cy="864096"/>
+          </a:xfrm>
+          <a:prstGeom prst="rect">
+            <a:avLst/>
+          </a:prstGeom>
+          <a:noFill/>
+          <a:ln>
+            <a:prstDash val="sysDot"/>
+          </a:ln>
+        </p:spPr>
+        <p:style>
+          <a:lnRef idx="2">
+            <a:schemeClr val="accent1">
+              <a:shade val="50000"/>
+            </a:schemeClr>
+          </a:lnRef>
+          <a:fillRef idx="1">
+            <a:schemeClr val="accent1"/>
+          </a:fillRef>
+          <a:effectRef idx="0">
+            <a:schemeClr val="accent1"/>
+          </a:effectRef>
+          <a:fontRef idx="minor">
+            <a:schemeClr val="lt1"/>
+          </a:fontRef>
+        </p:style>
+        <p:txBody>
+          <a:bodyPr rtlCol="0" anchor="ctr"/>
+          <a:lstStyle/>
+          <a:p>
+            <a:pPr algn="ctr"/>
+            <a:endParaRPr lang="ru-RU"/>
+          </a:p>
+        </p:txBody>
+      </p:sp>
+      <p:sp>
+        <p:nvSpPr>
+          <p:cNvPr id="43" name="TextBox 42"/>
+          <p:cNvSpPr txBox="1"/>
+          <p:nvPr/>
+        </p:nvSpPr>
+        <p:spPr>
+          <a:xfrm>
+            <a:off x="4283968" y="3213573"/>
+            <a:ext cx="1368152" cy="923330"/>
+          </a:xfrm>
+          <a:prstGeom prst="rect">
+            <a:avLst/>
+          </a:prstGeom>
+          <a:noFill/>
+        </p:spPr>
+        <p:txBody>
+          <a:bodyPr wrap="square" rtlCol="0">
+            <a:spAutoFit/>
+          </a:bodyPr>
+          <a:lstStyle/>
+          <a:p>
+            <a:pPr algn="ctr"/>
+            <a:r>
+              <a:rPr lang="en-US" dirty="0" smtClean="0"/>
+              <a:t>Data collection module</a:t>
+            </a:r>
+            <a:endParaRPr lang="ru-RU" dirty="0"/>
+          </a:p>
+        </p:txBody>
+      </p:sp>
+      <p:sp>
+        <p:nvSpPr>
+          <p:cNvPr id="53" name="Стрелка вправо 52"/>
+          <p:cNvSpPr/>
+          <p:nvPr/>
+        </p:nvSpPr>
+        <p:spPr>
+          <a:xfrm>
+            <a:off x="2267744" y="3592084"/>
+            <a:ext cx="2016225" cy="249896"/>
+          </a:xfrm>
+          <a:prstGeom prst="rightArrow">
+            <a:avLst/>
+          </a:prstGeom>
+        </p:spPr>
+        <p:style>
+          <a:lnRef idx="2">
+            <a:schemeClr val="accent1">
+              <a:shade val="50000"/>
+            </a:schemeClr>
+          </a:lnRef>
+          <a:fillRef idx="1">
+            <a:schemeClr val="accent1"/>
+          </a:fillRef>
+          <a:effectRef idx="0">
+            <a:schemeClr val="accent1"/>
+          </a:effectRef>
+          <a:fontRef idx="minor">
+            <a:schemeClr val="lt1"/>
+          </a:fontRef>
+        </p:style>
+        <p:txBody>
+          <a:bodyPr rtlCol="0" anchor="ctr"/>
+          <a:lstStyle/>
+          <a:p>
+            <a:pPr algn="ctr"/>
+            <a:endParaRPr lang="ru-RU"/>
+          </a:p>
+        </p:txBody>
+      </p:sp>
+      <p:sp>
+        <p:nvSpPr>
+          <p:cNvPr id="67" name="TextBox 66"/>
+          <p:cNvSpPr txBox="1"/>
+          <p:nvPr/>
+        </p:nvSpPr>
+        <p:spPr>
+          <a:xfrm>
+            <a:off x="755576" y="1444508"/>
+            <a:ext cx="792088" cy="400110"/>
+          </a:xfrm>
+          <a:prstGeom prst="rect">
+            <a:avLst/>
+          </a:prstGeom>
+          <a:noFill/>
+        </p:spPr>
+        <p:txBody>
+          <a:bodyPr wrap="square" rtlCol="0">
+            <a:spAutoFit/>
+          </a:bodyPr>
+          <a:lstStyle/>
+          <a:p>
+            <a:r>
+              <a:rPr lang="en-US" sz="2000" dirty="0" smtClean="0"/>
+              <a:t>PC_1</a:t>
+            </a:r>
+            <a:endParaRPr lang="ru-RU" sz="2000" dirty="0"/>
+          </a:p>
+        </p:txBody>
+      </p:sp>
+      <p:sp>
+        <p:nvSpPr>
+          <p:cNvPr id="51" name="Прямоугольник 50"/>
+          <p:cNvSpPr/>
+          <p:nvPr/>
+        </p:nvSpPr>
+        <p:spPr>
+          <a:xfrm>
+            <a:off x="2718994" y="2270426"/>
+            <a:ext cx="1368152" cy="864096"/>
+          </a:xfrm>
+          <a:prstGeom prst="rect">
+            <a:avLst/>
+          </a:prstGeom>
+          <a:noFill/>
+          <a:ln>
+            <a:prstDash val="sysDot"/>
+          </a:ln>
+        </p:spPr>
+        <p:style>
+          <a:lnRef idx="2">
+            <a:schemeClr val="accent1">
+              <a:shade val="50000"/>
+            </a:schemeClr>
+          </a:lnRef>
+          <a:fillRef idx="1">
+            <a:schemeClr val="accent1"/>
+          </a:fillRef>
+          <a:effectRef idx="0">
+            <a:schemeClr val="accent1"/>
+          </a:effectRef>
+          <a:fontRef idx="minor">
+            <a:schemeClr val="lt1"/>
+          </a:fontRef>
+        </p:style>
+        <p:txBody>
+          <a:bodyPr rtlCol="0" anchor="ctr"/>
+          <a:lstStyle/>
+          <a:p>
+            <a:pPr algn="ctr"/>
+            <a:endParaRPr lang="ru-RU"/>
+          </a:p>
+        </p:txBody>
+      </p:sp>
+      <p:sp>
+        <p:nvSpPr>
+          <p:cNvPr id="52" name="TextBox 51"/>
+          <p:cNvSpPr txBox="1"/>
+          <p:nvPr/>
+        </p:nvSpPr>
+        <p:spPr>
+          <a:xfrm>
+            <a:off x="2791000" y="2240809"/>
+            <a:ext cx="1216135" cy="923330"/>
+          </a:xfrm>
+          <a:prstGeom prst="rect">
+            <a:avLst/>
+          </a:prstGeom>
+          <a:noFill/>
+        </p:spPr>
+        <p:txBody>
+          <a:bodyPr wrap="square" rtlCol="0">
+            <a:spAutoFit/>
+          </a:bodyPr>
+          <a:lstStyle/>
+          <a:p>
+            <a:pPr algn="ctr"/>
+            <a:r>
+              <a:rPr lang="en-US" dirty="0" smtClean="0"/>
+              <a:t>Data processing module</a:t>
+            </a:r>
+            <a:endParaRPr lang="ru-RU" dirty="0"/>
+          </a:p>
+        </p:txBody>
+      </p:sp>
+      <p:sp>
+        <p:nvSpPr>
+          <p:cNvPr id="71" name="Стрелка вверх 70"/>
+          <p:cNvSpPr/>
+          <p:nvPr/>
+        </p:nvSpPr>
+        <p:spPr>
+          <a:xfrm>
+            <a:off x="4820024" y="2260665"/>
+            <a:ext cx="288032" cy="1024319"/>
+          </a:xfrm>
+          <a:prstGeom prst="upArrow">
+            <a:avLst/>
+          </a:prstGeom>
+          <a:solidFill>
+            <a:schemeClr val="accent1"/>
+          </a:solidFill>
+          <a:ln>
+            <a:prstDash val="solid"/>
+          </a:ln>
+        </p:spPr>
+        <p:style>
+          <a:lnRef idx="2">
+            <a:schemeClr val="accent1">
+              <a:shade val="50000"/>
+            </a:schemeClr>
+          </a:lnRef>
+          <a:fillRef idx="1">
+            <a:schemeClr val="accent1"/>
+          </a:fillRef>
+          <a:effectRef idx="0">
+            <a:schemeClr val="accent1"/>
+          </a:effectRef>
+          <a:fontRef idx="minor">
+            <a:schemeClr val="lt1"/>
+          </a:fontRef>
+        </p:style>
+        <p:txBody>
+          <a:bodyPr rtlCol="0" anchor="ctr"/>
+          <a:lstStyle/>
+          <a:p>
+            <a:pPr algn="ctr"/>
+            <a:endParaRPr lang="ru-RU"/>
+          </a:p>
+        </p:txBody>
+      </p:sp>
+      <p:sp>
+        <p:nvSpPr>
+          <p:cNvPr id="72" name="Прямоугольник 71"/>
+          <p:cNvSpPr/>
+          <p:nvPr/>
+        </p:nvSpPr>
+        <p:spPr>
+          <a:xfrm>
+            <a:off x="4274278" y="1377611"/>
+            <a:ext cx="1368152" cy="864096"/>
+          </a:xfrm>
+          <a:prstGeom prst="rect">
+            <a:avLst/>
+          </a:prstGeom>
+          <a:noFill/>
+          <a:ln>
+            <a:prstDash val="sysDot"/>
+          </a:ln>
+        </p:spPr>
+        <p:style>
+          <a:lnRef idx="2">
+            <a:schemeClr val="accent1">
+              <a:shade val="50000"/>
+            </a:schemeClr>
+          </a:lnRef>
+          <a:fillRef idx="1">
+            <a:schemeClr val="accent1"/>
+          </a:fillRef>
+          <a:effectRef idx="0">
+            <a:schemeClr val="accent1"/>
+          </a:effectRef>
+          <a:fontRef idx="minor">
+            <a:schemeClr val="lt1"/>
+          </a:fontRef>
+        </p:style>
+        <p:txBody>
+          <a:bodyPr rtlCol="0" anchor="ctr"/>
+          <a:lstStyle/>
+          <a:p>
+            <a:pPr algn="ctr"/>
+            <a:endParaRPr lang="ru-RU"/>
+          </a:p>
+        </p:txBody>
+      </p:sp>
+      <p:sp>
+        <p:nvSpPr>
+          <p:cNvPr id="73" name="TextBox 72"/>
+          <p:cNvSpPr txBox="1"/>
+          <p:nvPr/>
+        </p:nvSpPr>
+        <p:spPr>
+          <a:xfrm>
+            <a:off x="4268713" y="1369633"/>
+            <a:ext cx="1368152" cy="923330"/>
+          </a:xfrm>
+          <a:prstGeom prst="rect">
+            <a:avLst/>
+          </a:prstGeom>
+          <a:noFill/>
+        </p:spPr>
+        <p:txBody>
+          <a:bodyPr wrap="square" rtlCol="0">
+            <a:spAutoFit/>
+          </a:bodyPr>
+          <a:lstStyle/>
+          <a:p>
+            <a:pPr algn="ctr"/>
+            <a:r>
+              <a:rPr lang="en-US" dirty="0" smtClean="0"/>
+              <a:t>Data</a:t>
+            </a:r>
+          </a:p>
+          <a:p>
+            <a:pPr algn="ctr"/>
+            <a:r>
+              <a:rPr lang="en-US" dirty="0" smtClean="0"/>
+              <a:t>storage module</a:t>
+            </a:r>
+            <a:endParaRPr lang="ru-RU" dirty="0"/>
+          </a:p>
+        </p:txBody>
+      </p:sp>
+      <p:sp>
+        <p:nvSpPr>
+          <p:cNvPr id="78" name="Прямоугольник 77"/>
+          <p:cNvSpPr/>
+          <p:nvPr/>
+        </p:nvSpPr>
+        <p:spPr>
+          <a:xfrm>
+            <a:off x="4283968" y="4437112"/>
+            <a:ext cx="1368152" cy="864096"/>
+          </a:xfrm>
+          <a:prstGeom prst="rect">
+            <a:avLst/>
+          </a:prstGeom>
+          <a:noFill/>
+          <a:ln w="31750">
+            <a:prstDash val="sysDot"/>
+          </a:ln>
+        </p:spPr>
+        <p:style>
+          <a:lnRef idx="2">
+            <a:schemeClr val="accent1">
+              <a:shade val="50000"/>
+            </a:schemeClr>
+          </a:lnRef>
+          <a:fillRef idx="1">
+            <a:schemeClr val="accent1"/>
+          </a:fillRef>
+          <a:effectRef idx="0">
+            <a:schemeClr val="accent1"/>
+          </a:effectRef>
+          <a:fontRef idx="minor">
+            <a:schemeClr val="lt1"/>
+          </a:fontRef>
+        </p:style>
+        <p:txBody>
+          <a:bodyPr rtlCol="0" anchor="ctr"/>
+          <a:lstStyle/>
+          <a:p>
+            <a:pPr algn="ctr"/>
+            <a:endParaRPr lang="ru-RU"/>
+          </a:p>
+        </p:txBody>
+      </p:sp>
+      <p:sp>
+        <p:nvSpPr>
+          <p:cNvPr id="79" name="TextBox 78"/>
+          <p:cNvSpPr txBox="1"/>
+          <p:nvPr/>
+        </p:nvSpPr>
+        <p:spPr>
+          <a:xfrm>
+            <a:off x="4342801" y="4545994"/>
+            <a:ext cx="1250486" cy="646331"/>
+          </a:xfrm>
+          <a:prstGeom prst="rect">
+            <a:avLst/>
+          </a:prstGeom>
+          <a:noFill/>
+        </p:spPr>
+        <p:txBody>
+          <a:bodyPr wrap="square" rtlCol="0">
+            <a:spAutoFit/>
+          </a:bodyPr>
+          <a:lstStyle/>
+          <a:p>
+            <a:pPr algn="ctr"/>
+            <a:r>
+              <a:rPr lang="en-US" dirty="0" smtClean="0"/>
+              <a:t>Controller</a:t>
+            </a:r>
+          </a:p>
+          <a:p>
+            <a:pPr algn="ctr"/>
+            <a:r>
+              <a:rPr lang="en-US" dirty="0" smtClean="0"/>
+              <a:t>Module</a:t>
+            </a:r>
+            <a:endParaRPr lang="ru-RU" dirty="0"/>
+          </a:p>
+        </p:txBody>
+      </p:sp>
+      <p:sp>
+        <p:nvSpPr>
+          <p:cNvPr id="88" name="TextBox 87"/>
+          <p:cNvSpPr txBox="1"/>
+          <p:nvPr/>
+        </p:nvSpPr>
+        <p:spPr>
+          <a:xfrm>
+            <a:off x="1894529" y="4545993"/>
+            <a:ext cx="1250486" cy="646331"/>
+          </a:xfrm>
+          <a:prstGeom prst="rect">
+            <a:avLst/>
+          </a:prstGeom>
+          <a:noFill/>
+        </p:spPr>
+        <p:txBody>
+          <a:bodyPr wrap="square" rtlCol="0">
+            <a:spAutoFit/>
+          </a:bodyPr>
+          <a:lstStyle/>
+          <a:p>
+            <a:pPr algn="ctr"/>
+            <a:r>
+              <a:rPr lang="en-US" dirty="0" smtClean="0"/>
+              <a:t>Logg</a:t>
+            </a:r>
+            <a:r>
+              <a:rPr lang="en-US" dirty="0" smtClean="0"/>
+              <a:t>er</a:t>
+            </a:r>
+          </a:p>
+          <a:p>
+            <a:pPr algn="ctr"/>
+            <a:r>
+              <a:rPr lang="en-US" dirty="0" smtClean="0"/>
+              <a:t>Module</a:t>
+            </a:r>
+            <a:endParaRPr lang="ru-RU" dirty="0"/>
+          </a:p>
+        </p:txBody>
+      </p:sp>
+      <p:sp>
+        <p:nvSpPr>
+          <p:cNvPr id="89" name="Прямоугольник 88"/>
+          <p:cNvSpPr/>
+          <p:nvPr/>
+        </p:nvSpPr>
+        <p:spPr>
+          <a:xfrm>
+            <a:off x="1838650" y="5445224"/>
+            <a:ext cx="1368152" cy="864096"/>
+          </a:xfrm>
+          <a:prstGeom prst="rect">
+            <a:avLst/>
+          </a:prstGeom>
+          <a:noFill/>
+          <a:ln>
+            <a:prstDash val="sysDot"/>
+          </a:ln>
+        </p:spPr>
+        <p:style>
+          <a:lnRef idx="2">
+            <a:schemeClr val="accent1">
+              <a:shade val="50000"/>
+            </a:schemeClr>
+          </a:lnRef>
+          <a:fillRef idx="1">
+            <a:schemeClr val="accent1"/>
+          </a:fillRef>
+          <a:effectRef idx="0">
+            <a:schemeClr val="accent1"/>
+          </a:effectRef>
+          <a:fontRef idx="minor">
+            <a:schemeClr val="lt1"/>
+          </a:fontRef>
+        </p:style>
+        <p:txBody>
+          <a:bodyPr rtlCol="0" anchor="ctr"/>
+          <a:lstStyle/>
+          <a:p>
+            <a:pPr algn="ctr"/>
+            <a:endParaRPr lang="ru-RU"/>
+          </a:p>
+        </p:txBody>
+      </p:sp>
+      <p:sp>
+        <p:nvSpPr>
+          <p:cNvPr id="90" name="TextBox 89"/>
+          <p:cNvSpPr txBox="1"/>
+          <p:nvPr/>
+        </p:nvSpPr>
+        <p:spPr>
+          <a:xfrm>
+            <a:off x="1894529" y="5571326"/>
+            <a:ext cx="1250486" cy="646331"/>
+          </a:xfrm>
+          <a:prstGeom prst="rect">
+            <a:avLst/>
+          </a:prstGeom>
+          <a:noFill/>
+        </p:spPr>
+        <p:txBody>
+          <a:bodyPr wrap="square" rtlCol="0">
+            <a:spAutoFit/>
+          </a:bodyPr>
+          <a:lstStyle/>
+          <a:p>
+            <a:pPr algn="ctr"/>
+            <a:r>
+              <a:rPr lang="en-US" dirty="0" smtClean="0"/>
+              <a:t>Messenger</a:t>
+            </a:r>
+          </a:p>
+          <a:p>
+            <a:pPr algn="ctr"/>
+            <a:r>
+              <a:rPr lang="en-US" dirty="0" smtClean="0"/>
+              <a:t>Module</a:t>
+            </a:r>
+            <a:endParaRPr lang="ru-RU" dirty="0"/>
+          </a:p>
+        </p:txBody>
+      </p:sp>
+      <p:sp>
+        <p:nvSpPr>
+          <p:cNvPr id="95" name="Прямоугольник 94"/>
+          <p:cNvSpPr/>
+          <p:nvPr/>
+        </p:nvSpPr>
+        <p:spPr>
+          <a:xfrm>
+            <a:off x="4279964" y="5589240"/>
+            <a:ext cx="1368152" cy="864096"/>
+          </a:xfrm>
+          <a:prstGeom prst="rect">
+            <a:avLst/>
+          </a:prstGeom>
+          <a:noFill/>
+          <a:ln>
+            <a:prstDash val="sysDot"/>
+          </a:ln>
+        </p:spPr>
+        <p:style>
+          <a:lnRef idx="2">
+            <a:schemeClr val="accent1">
+              <a:shade val="50000"/>
+            </a:schemeClr>
+          </a:lnRef>
+          <a:fillRef idx="1">
+            <a:schemeClr val="accent1"/>
+          </a:fillRef>
+          <a:effectRef idx="0">
+            <a:schemeClr val="accent1"/>
+          </a:effectRef>
+          <a:fontRef idx="minor">
+            <a:schemeClr val="lt1"/>
+          </a:fontRef>
+        </p:style>
+        <p:txBody>
+          <a:bodyPr rtlCol="0" anchor="ctr"/>
+          <a:lstStyle/>
+          <a:p>
+            <a:pPr algn="ctr"/>
+            <a:endParaRPr lang="ru-RU"/>
+          </a:p>
+        </p:txBody>
+      </p:sp>
+      <p:sp>
+        <p:nvSpPr>
+          <p:cNvPr id="96" name="TextBox 95"/>
+          <p:cNvSpPr txBox="1"/>
+          <p:nvPr/>
+        </p:nvSpPr>
+        <p:spPr>
+          <a:xfrm>
+            <a:off x="4211960" y="5575953"/>
+            <a:ext cx="1512168" cy="923330"/>
+          </a:xfrm>
+          <a:prstGeom prst="rect">
+            <a:avLst/>
+          </a:prstGeom>
+          <a:noFill/>
+        </p:spPr>
+        <p:txBody>
+          <a:bodyPr wrap="square" rtlCol="0">
+            <a:spAutoFit/>
+          </a:bodyPr>
+          <a:lstStyle/>
+          <a:p>
+            <a:pPr algn="ctr"/>
+            <a:r>
+              <a:rPr lang="en-US" dirty="0" smtClean="0"/>
+              <a:t>Configuration Reader</a:t>
+            </a:r>
+          </a:p>
+          <a:p>
+            <a:pPr algn="ctr"/>
+            <a:r>
+              <a:rPr lang="en-US" dirty="0" smtClean="0"/>
+              <a:t>Module</a:t>
+            </a:r>
+            <a:endParaRPr lang="ru-RU" dirty="0"/>
+          </a:p>
+        </p:txBody>
+      </p:sp>
+      <p:sp>
+        <p:nvSpPr>
+          <p:cNvPr id="105" name="Прямоугольник 104"/>
+          <p:cNvSpPr/>
+          <p:nvPr/>
+        </p:nvSpPr>
+        <p:spPr>
+          <a:xfrm>
+            <a:off x="5828136" y="2270426"/>
+            <a:ext cx="1368152" cy="864096"/>
+          </a:xfrm>
+          <a:prstGeom prst="rect">
+            <a:avLst/>
+          </a:prstGeom>
+          <a:noFill/>
+          <a:ln>
+            <a:prstDash val="sysDot"/>
+          </a:ln>
+        </p:spPr>
+        <p:style>
+          <a:lnRef idx="2">
+            <a:schemeClr val="accent1">
+              <a:shade val="50000"/>
+            </a:schemeClr>
+          </a:lnRef>
+          <a:fillRef idx="1">
+            <a:schemeClr val="accent1"/>
+          </a:fillRef>
+          <a:effectRef idx="0">
+            <a:schemeClr val="accent1"/>
+          </a:effectRef>
+          <a:fontRef idx="minor">
+            <a:schemeClr val="lt1"/>
+          </a:fontRef>
+        </p:style>
+        <p:txBody>
+          <a:bodyPr rtlCol="0" anchor="ctr"/>
+          <a:lstStyle/>
+          <a:p>
+            <a:pPr algn="ctr"/>
+            <a:endParaRPr lang="ru-RU"/>
+          </a:p>
+        </p:txBody>
+      </p:sp>
+      <p:sp>
+        <p:nvSpPr>
+          <p:cNvPr id="106" name="TextBox 105"/>
+          <p:cNvSpPr txBox="1"/>
+          <p:nvPr/>
+        </p:nvSpPr>
+        <p:spPr>
+          <a:xfrm>
+            <a:off x="5886969" y="2266734"/>
+            <a:ext cx="1250486" cy="923330"/>
+          </a:xfrm>
+          <a:prstGeom prst="rect">
+            <a:avLst/>
+          </a:prstGeom>
+          <a:noFill/>
+        </p:spPr>
+        <p:txBody>
+          <a:bodyPr wrap="square" rtlCol="0">
+            <a:spAutoFit/>
+          </a:bodyPr>
+          <a:lstStyle/>
+          <a:p>
+            <a:pPr algn="ctr"/>
+            <a:r>
+              <a:rPr lang="en-US" dirty="0" smtClean="0"/>
+              <a:t>System Validation</a:t>
+            </a:r>
+          </a:p>
+          <a:p>
+            <a:pPr algn="ctr"/>
+            <a:r>
+              <a:rPr lang="en-US" dirty="0" smtClean="0"/>
+              <a:t>Module</a:t>
+            </a:r>
+            <a:endParaRPr lang="ru-RU" dirty="0"/>
+          </a:p>
+        </p:txBody>
+      </p:sp>
+      <p:sp>
+        <p:nvSpPr>
+          <p:cNvPr id="3" name="Тройная стрелка влево/вправо/вверх 2"/>
+          <p:cNvSpPr/>
+          <p:nvPr/>
+        </p:nvSpPr>
+        <p:spPr>
+          <a:xfrm>
+            <a:off x="4099944" y="2260665"/>
+            <a:ext cx="1728192" cy="583693"/>
+          </a:xfrm>
+          <a:prstGeom prst="leftRightUpArrow">
+            <a:avLst/>
+          </a:prstGeom>
+        </p:spPr>
+        <p:style>
+          <a:lnRef idx="2">
+            <a:schemeClr val="accent1">
+              <a:shade val="50000"/>
+            </a:schemeClr>
+          </a:lnRef>
+          <a:fillRef idx="1">
+            <a:schemeClr val="accent1"/>
+          </a:fillRef>
+          <a:effectRef idx="0">
+            <a:schemeClr val="accent1"/>
+          </a:effectRef>
+          <a:fontRef idx="minor">
+            <a:schemeClr val="lt1"/>
+          </a:fontRef>
+        </p:style>
+        <p:txBody>
+          <a:bodyPr rtlCol="0" anchor="ctr"/>
+          <a:lstStyle/>
+          <a:p>
+            <a:pPr algn="ctr"/>
+            <a:endParaRPr lang="ru-RU"/>
+          </a:p>
+        </p:txBody>
+      </p:sp>
+      <p:cxnSp>
+        <p:nvCxnSpPr>
+          <p:cNvPr id="7" name="Прямая со стрелкой 6"/>
+          <p:cNvCxnSpPr/>
+          <p:nvPr/>
+        </p:nvCxnSpPr>
+        <p:spPr>
+          <a:xfrm flipH="1" flipV="1">
+            <a:off x="3191312" y="4869159"/>
+            <a:ext cx="1082966" cy="1"/>
+          </a:xfrm>
+          <a:prstGeom prst="straightConnector1">
+            <a:avLst/>
+          </a:prstGeom>
+          <a:ln w="15875">
+            <a:solidFill>
+              <a:schemeClr val="tx1"/>
+            </a:solidFill>
+            <a:tailEnd type="stealth"/>
+          </a:ln>
+        </p:spPr>
+        <p:style>
+          <a:lnRef idx="1">
+            <a:schemeClr val="accent1"/>
+          </a:lnRef>
+          <a:fillRef idx="0">
+            <a:schemeClr val="accent1"/>
+          </a:fillRef>
+          <a:effectRef idx="0">
+            <a:schemeClr val="accent1"/>
+          </a:effectRef>
+          <a:fontRef idx="minor">
+            <a:schemeClr val="tx1"/>
+          </a:fontRef>
+        </p:style>
+      </p:cxnSp>
+      <p:cxnSp>
+        <p:nvCxnSpPr>
+          <p:cNvPr id="107" name="Прямая со стрелкой 106"/>
+          <p:cNvCxnSpPr/>
+          <p:nvPr/>
+        </p:nvCxnSpPr>
+        <p:spPr>
+          <a:xfrm flipH="1">
+            <a:off x="3203850" y="5868766"/>
+            <a:ext cx="288030" cy="0"/>
+          </a:xfrm>
+          <a:prstGeom prst="straightConnector1">
+            <a:avLst/>
+          </a:prstGeom>
+          <a:ln w="15875">
+            <a:solidFill>
+              <a:schemeClr val="tx1"/>
+            </a:solidFill>
+            <a:tailEnd type="stealth"/>
+          </a:ln>
+        </p:spPr>
+        <p:style>
+          <a:lnRef idx="1">
+            <a:schemeClr val="accent1"/>
+          </a:lnRef>
+          <a:fillRef idx="0">
+            <a:schemeClr val="accent1"/>
+          </a:fillRef>
+          <a:effectRef idx="0">
+            <a:schemeClr val="accent1"/>
+          </a:effectRef>
+          <a:fontRef idx="minor">
+            <a:schemeClr val="tx1"/>
+          </a:fontRef>
+        </p:style>
+      </p:cxnSp>
+      <p:cxnSp>
+        <p:nvCxnSpPr>
+          <p:cNvPr id="108" name="Прямая со стрелкой 107"/>
+          <p:cNvCxnSpPr>
+            <a:stCxn id="78" idx="0"/>
+            <a:endCxn id="42" idx="2"/>
+          </p:cNvCxnSpPr>
+          <p:nvPr/>
+        </p:nvCxnSpPr>
+        <p:spPr>
+          <a:xfrm flipV="1">
+            <a:off x="4968044" y="4149080"/>
+            <a:ext cx="0" cy="288032"/>
+          </a:xfrm>
+          <a:prstGeom prst="straightConnector1">
+            <a:avLst/>
+          </a:prstGeom>
+          <a:ln w="15875">
+            <a:solidFill>
+              <a:schemeClr val="tx1"/>
+            </a:solidFill>
+            <a:tailEnd type="stealth"/>
+          </a:ln>
+        </p:spPr>
+        <p:style>
+          <a:lnRef idx="1">
+            <a:schemeClr val="accent1"/>
+          </a:lnRef>
+          <a:fillRef idx="0">
+            <a:schemeClr val="accent1"/>
+          </a:fillRef>
+          <a:effectRef idx="0">
+            <a:schemeClr val="accent1"/>
+          </a:effectRef>
+          <a:fontRef idx="minor">
+            <a:schemeClr val="tx1"/>
+          </a:fontRef>
+        </p:style>
+      </p:cxnSp>
+      <p:cxnSp>
+        <p:nvCxnSpPr>
+          <p:cNvPr id="110" name="Прямая со стрелкой 109"/>
+          <p:cNvCxnSpPr/>
+          <p:nvPr/>
+        </p:nvCxnSpPr>
+        <p:spPr>
+          <a:xfrm flipV="1">
+            <a:off x="4959745" y="5287921"/>
+            <a:ext cx="0" cy="288032"/>
+          </a:xfrm>
+          <a:prstGeom prst="straightConnector1">
+            <a:avLst/>
+          </a:prstGeom>
+          <a:ln w="15875">
+            <a:solidFill>
+              <a:schemeClr val="tx1"/>
+            </a:solidFill>
+            <a:tailEnd type="stealth"/>
+          </a:ln>
+        </p:spPr>
+        <p:style>
+          <a:lnRef idx="1">
+            <a:schemeClr val="accent1"/>
+          </a:lnRef>
+          <a:fillRef idx="0">
+            <a:schemeClr val="accent1"/>
+          </a:fillRef>
+          <a:effectRef idx="0">
+            <a:schemeClr val="accent1"/>
+          </a:effectRef>
+          <a:fontRef idx="minor">
+            <a:schemeClr val="tx1"/>
+          </a:fontRef>
+        </p:style>
+      </p:cxnSp>
+      <p:cxnSp>
+        <p:nvCxnSpPr>
+          <p:cNvPr id="111" name="Прямая со стрелкой 110"/>
+          <p:cNvCxnSpPr/>
+          <p:nvPr/>
+        </p:nvCxnSpPr>
+        <p:spPr>
+          <a:xfrm flipV="1">
+            <a:off x="6501941" y="3140968"/>
+            <a:ext cx="0" cy="1512168"/>
+          </a:xfrm>
+          <a:prstGeom prst="straightConnector1">
+            <a:avLst/>
+          </a:prstGeom>
+          <a:ln w="15875">
+            <a:solidFill>
+              <a:schemeClr val="tx1"/>
+            </a:solidFill>
+            <a:tailEnd type="none"/>
+          </a:ln>
+        </p:spPr>
+        <p:style>
+          <a:lnRef idx="1">
+            <a:schemeClr val="accent1"/>
+          </a:lnRef>
+          <a:fillRef idx="0">
+            <a:schemeClr val="accent1"/>
+          </a:fillRef>
+          <a:effectRef idx="0">
+            <a:schemeClr val="accent1"/>
+          </a:effectRef>
+          <a:fontRef idx="minor">
+            <a:schemeClr val="tx1"/>
+          </a:fontRef>
+        </p:style>
+      </p:cxnSp>
+      <p:cxnSp>
+        <p:nvCxnSpPr>
+          <p:cNvPr id="112" name="Прямая со стрелкой 111"/>
+          <p:cNvCxnSpPr/>
+          <p:nvPr/>
+        </p:nvCxnSpPr>
+        <p:spPr>
+          <a:xfrm flipH="1">
+            <a:off x="5642431" y="4653136"/>
+            <a:ext cx="859510" cy="0"/>
+          </a:xfrm>
+          <a:prstGeom prst="straightConnector1">
+            <a:avLst/>
+          </a:prstGeom>
+          <a:ln w="15875">
+            <a:solidFill>
+              <a:schemeClr val="tx1"/>
+            </a:solidFill>
+            <a:tailEnd type="stealth"/>
+          </a:ln>
+        </p:spPr>
+        <p:style>
+          <a:lnRef idx="1">
+            <a:schemeClr val="accent1"/>
+          </a:lnRef>
+          <a:fillRef idx="0">
+            <a:schemeClr val="accent1"/>
+          </a:fillRef>
+          <a:effectRef idx="0">
+            <a:schemeClr val="accent1"/>
+          </a:effectRef>
+          <a:fontRef idx="minor">
+            <a:schemeClr val="tx1"/>
+          </a:fontRef>
+        </p:style>
+      </p:cxnSp>
+      <p:cxnSp>
+        <p:nvCxnSpPr>
+          <p:cNvPr id="113" name="Прямая со стрелкой 112"/>
+          <p:cNvCxnSpPr/>
+          <p:nvPr/>
+        </p:nvCxnSpPr>
+        <p:spPr>
+          <a:xfrm flipV="1">
+            <a:off x="3491880" y="3106034"/>
+            <a:ext cx="0" cy="2762732"/>
+          </a:xfrm>
+          <a:prstGeom prst="straightConnector1">
+            <a:avLst/>
+          </a:prstGeom>
+          <a:ln w="15875">
+            <a:solidFill>
+              <a:schemeClr val="tx1"/>
+            </a:solidFill>
+            <a:tailEnd type="stealth"/>
+          </a:ln>
+        </p:spPr>
+        <p:style>
+          <a:lnRef idx="1">
+            <a:schemeClr val="accent1"/>
+          </a:lnRef>
+          <a:fillRef idx="0">
+            <a:schemeClr val="accent1"/>
+          </a:fillRef>
+          <a:effectRef idx="0">
+            <a:schemeClr val="accent1"/>
+          </a:effectRef>
+          <a:fontRef idx="minor">
+            <a:schemeClr val="tx1"/>
+          </a:fontRef>
+        </p:style>
+      </p:cxnSp>
+      <p:cxnSp>
+        <p:nvCxnSpPr>
+          <p:cNvPr id="115" name="Прямая со стрелкой 114"/>
+          <p:cNvCxnSpPr/>
+          <p:nvPr/>
+        </p:nvCxnSpPr>
+        <p:spPr>
+          <a:xfrm flipH="1">
+            <a:off x="5636865" y="1809659"/>
+            <a:ext cx="1876018" cy="0"/>
+          </a:xfrm>
+          <a:prstGeom prst="straightConnector1">
+            <a:avLst/>
+          </a:prstGeom>
+          <a:ln w="15875">
+            <a:solidFill>
+              <a:schemeClr val="tx1"/>
+            </a:solidFill>
+            <a:tailEnd type="stealth"/>
+          </a:ln>
+        </p:spPr>
+        <p:style>
+          <a:lnRef idx="1">
+            <a:schemeClr val="accent1"/>
+          </a:lnRef>
+          <a:fillRef idx="0">
+            <a:schemeClr val="accent1"/>
+          </a:fillRef>
+          <a:effectRef idx="0">
+            <a:schemeClr val="accent1"/>
+          </a:effectRef>
+          <a:fontRef idx="minor">
+            <a:schemeClr val="tx1"/>
+          </a:fontRef>
+        </p:style>
+      </p:cxnSp>
+      <p:cxnSp>
+        <p:nvCxnSpPr>
+          <p:cNvPr id="120" name="Прямая со стрелкой 119"/>
+          <p:cNvCxnSpPr/>
+          <p:nvPr/>
+        </p:nvCxnSpPr>
+        <p:spPr>
+          <a:xfrm flipH="1" flipV="1">
+            <a:off x="7512135" y="1830965"/>
+            <a:ext cx="374" cy="3203517"/>
+          </a:xfrm>
+          <a:prstGeom prst="straightConnector1">
+            <a:avLst/>
+          </a:prstGeom>
+          <a:ln w="15875">
+            <a:solidFill>
+              <a:schemeClr val="tx1"/>
+            </a:solidFill>
+            <a:tailEnd type="none"/>
+          </a:ln>
+        </p:spPr>
+        <p:style>
+          <a:lnRef idx="1">
+            <a:schemeClr val="accent1"/>
+          </a:lnRef>
+          <a:fillRef idx="0">
+            <a:schemeClr val="accent1"/>
+          </a:fillRef>
+          <a:effectRef idx="0">
+            <a:schemeClr val="accent1"/>
+          </a:effectRef>
+          <a:fontRef idx="minor">
+            <a:schemeClr val="tx1"/>
+          </a:fontRef>
+        </p:style>
+      </p:cxnSp>
+      <p:cxnSp>
+        <p:nvCxnSpPr>
+          <p:cNvPr id="122" name="Прямая со стрелкой 121"/>
+          <p:cNvCxnSpPr/>
+          <p:nvPr/>
+        </p:nvCxnSpPr>
+        <p:spPr>
+          <a:xfrm flipH="1">
+            <a:off x="5652119" y="5030282"/>
+            <a:ext cx="1860016" cy="0"/>
+          </a:xfrm>
+          <a:prstGeom prst="straightConnector1">
+            <a:avLst/>
+          </a:prstGeom>
+          <a:ln w="15875">
+            <a:solidFill>
+              <a:schemeClr val="tx1"/>
+            </a:solidFill>
+            <a:tailEnd type="none"/>
+          </a:ln>
+        </p:spPr>
+        <p:style>
+          <a:lnRef idx="1">
+            <a:schemeClr val="accent1"/>
+          </a:lnRef>
+          <a:fillRef idx="0">
+            <a:schemeClr val="accent1"/>
+          </a:fillRef>
+          <a:effectRef idx="0">
+            <a:schemeClr val="accent1"/>
+          </a:effectRef>
+          <a:fontRef idx="minor">
+            <a:schemeClr val="tx1"/>
+          </a:fontRef>
+        </p:style>
+      </p:cxnSp>
+      <p:sp>
+        <p:nvSpPr>
+          <p:cNvPr id="130" name="Прямоугольник 129"/>
+          <p:cNvSpPr/>
+          <p:nvPr/>
+        </p:nvSpPr>
+        <p:spPr>
+          <a:xfrm>
+            <a:off x="1691680" y="1268760"/>
+            <a:ext cx="5976664" cy="5328592"/>
+          </a:xfrm>
+          <a:prstGeom prst="rect">
+            <a:avLst/>
+          </a:prstGeom>
+          <a:noFill/>
+          <a:ln w="25400">
+            <a:solidFill>
+              <a:srgbClr val="FF0000"/>
+            </a:solidFill>
+            <a:prstDash val="dash"/>
+          </a:ln>
+        </p:spPr>
+        <p:style>
+          <a:lnRef idx="2">
+            <a:schemeClr val="accent1">
+              <a:shade val="50000"/>
+            </a:schemeClr>
+          </a:lnRef>
+          <a:fillRef idx="1">
+            <a:schemeClr val="accent1"/>
+          </a:fillRef>
+          <a:effectRef idx="0">
+            <a:schemeClr val="accent1"/>
+          </a:effectRef>
+          <a:fontRef idx="minor">
+            <a:schemeClr val="lt1"/>
+          </a:fontRef>
+        </p:style>
+        <p:txBody>
+          <a:bodyPr rtlCol="0" anchor="ctr"/>
+          <a:lstStyle/>
+          <a:p>
+            <a:pPr algn="ctr"/>
+            <a:endParaRPr lang="ru-RU" dirty="0">
+              <a:solidFill>
+                <a:schemeClr val="tx1"/>
+              </a:solidFill>
+            </a:endParaRPr>
+          </a:p>
+        </p:txBody>
+      </p:sp>
+      <p:sp>
+        <p:nvSpPr>
+          <p:cNvPr id="131" name="TextBox 130"/>
+          <p:cNvSpPr txBox="1"/>
+          <p:nvPr/>
+        </p:nvSpPr>
+        <p:spPr>
+          <a:xfrm>
+            <a:off x="1835696" y="3350418"/>
+            <a:ext cx="1535565" cy="307777"/>
+          </a:xfrm>
+          <a:prstGeom prst="rect">
+            <a:avLst/>
+          </a:prstGeom>
+          <a:noFill/>
+        </p:spPr>
+        <p:txBody>
+          <a:bodyPr wrap="square" rtlCol="0">
+            <a:spAutoFit/>
+          </a:bodyPr>
+          <a:lstStyle/>
+          <a:p>
+            <a:pPr algn="ctr"/>
+            <a:r>
+              <a:rPr lang="en-US" sz="1400" i="1" dirty="0" smtClean="0"/>
+              <a:t>Sensors Data Flow</a:t>
+            </a:r>
+            <a:endParaRPr lang="ru-RU" sz="1400" i="1" dirty="0"/>
+          </a:p>
+        </p:txBody>
+      </p:sp>
+      <p:sp>
+        <p:nvSpPr>
+          <p:cNvPr id="132" name="Стрелка влево 131"/>
+          <p:cNvSpPr/>
+          <p:nvPr/>
+        </p:nvSpPr>
+        <p:spPr>
+          <a:xfrm>
+            <a:off x="3959364" y="1688826"/>
+            <a:ext cx="314914" cy="241666"/>
+          </a:xfrm>
+          <a:prstGeom prst="leftArrow">
+            <a:avLst/>
+          </a:prstGeom>
+          <a:ln>
+            <a:prstDash val="sysDot"/>
+          </a:ln>
+        </p:spPr>
+        <p:style>
+          <a:lnRef idx="2">
+            <a:schemeClr val="accent1">
+              <a:shade val="50000"/>
+            </a:schemeClr>
+          </a:lnRef>
+          <a:fillRef idx="1">
+            <a:schemeClr val="accent1"/>
+          </a:fillRef>
+          <a:effectRef idx="0">
+            <a:schemeClr val="accent1"/>
+          </a:effectRef>
+          <a:fontRef idx="minor">
+            <a:schemeClr val="lt1"/>
+          </a:fontRef>
+        </p:style>
+        <p:txBody>
+          <a:bodyPr rtlCol="0" anchor="ctr"/>
+          <a:lstStyle/>
+          <a:p>
+            <a:pPr algn="ctr"/>
+            <a:endParaRPr lang="ru-RU"/>
+          </a:p>
+        </p:txBody>
+      </p:sp>
+      <p:sp>
+        <p:nvSpPr>
+          <p:cNvPr id="133" name="Стрелка влево 132"/>
+          <p:cNvSpPr/>
+          <p:nvPr/>
+        </p:nvSpPr>
+        <p:spPr>
+          <a:xfrm>
+            <a:off x="2404080" y="2581641"/>
+            <a:ext cx="314914" cy="241666"/>
+          </a:xfrm>
+          <a:prstGeom prst="leftArrow">
+            <a:avLst/>
+          </a:prstGeom>
+          <a:ln>
+            <a:prstDash val="sysDot"/>
+          </a:ln>
+        </p:spPr>
+        <p:style>
+          <a:lnRef idx="2">
+            <a:schemeClr val="accent1">
+              <a:shade val="50000"/>
+            </a:schemeClr>
+          </a:lnRef>
+          <a:fillRef idx="1">
+            <a:schemeClr val="accent1"/>
+          </a:fillRef>
+          <a:effectRef idx="0">
+            <a:schemeClr val="accent1"/>
+          </a:effectRef>
+          <a:fontRef idx="minor">
+            <a:schemeClr val="lt1"/>
+          </a:fontRef>
+        </p:style>
+        <p:txBody>
+          <a:bodyPr rtlCol="0" anchor="ctr"/>
+          <a:lstStyle/>
+          <a:p>
+            <a:pPr algn="ctr"/>
+            <a:endParaRPr lang="ru-RU"/>
+          </a:p>
+        </p:txBody>
+      </p:sp>
+    </p:spTree>
+    <p:extLst>
+      <p:ext uri="{BB962C8B-B14F-4D97-AF65-F5344CB8AC3E}">
+        <p14:creationId xmlns:p14="http://schemas.microsoft.com/office/powerpoint/2010/main" val="2956225485"/>
+      </p:ext>
+    </p:extLst>
+  </p:cSld>
+  <p:clrMapOvr>
+    <a:masterClrMapping/>
+  </p:clrMapOvr>
+  <p:timing>
+    <p:tnLst>
+      <p:par>
+        <p:cTn id="1" dur="indefinite" restart="never" nodeType="tmRoot"/>
+      </p:par>
+    </p:tnLst>
+  </p:timing>
+</p:sld>
+</file>
+
+<file path=ppt/slides/slide6.xml><?xml version="1.0" encoding="utf-8"?>
+<p:sld xmlns:a="http://schemas.openxmlformats.org/drawingml/2006/main" xmlns:r="http://schemas.openxmlformats.org/officeDocument/2006/relationships" xmlns:p="http://schemas.openxmlformats.org/presentationml/2006/main">
+  <p:cSld>
+    <p:spTree>
+      <p:nvGrpSpPr>
+        <p:cNvPr id="1" name=""/>
+        <p:cNvGrpSpPr/>
+        <p:nvPr/>
+      </p:nvGrpSpPr>
+      <p:grpSpPr>
+        <a:xfrm>
+          <a:off x="0" y="0"/>
+          <a:ext cx="0" cy="0"/>
+          <a:chOff x="0" y="0"/>
+          <a:chExt cx="0" cy="0"/>
+        </a:xfrm>
+      </p:grpSpPr>
+      <p:sp>
+        <p:nvSpPr>
+          <p:cNvPr id="2" name="Заголовок 1"/>
+          <p:cNvSpPr>
+            <a:spLocks noGrp="1"/>
+          </p:cNvSpPr>
+          <p:nvPr>
+            <p:ph type="title"/>
+          </p:nvPr>
+        </p:nvSpPr>
+        <p:spPr>
+          <a:xfrm>
             <a:off x="457200" y="188640"/>
             <a:ext cx="8229600" cy="720080"/>
           </a:xfrm>
@@ -9154,7 +10645,7 @@
 </p:sld>
 </file>
 
-<file path=ppt/slides/slide6.xml><?xml version="1.0" encoding="utf-8"?>
+<file path=ppt/slides/slide7.xml><?xml version="1.0" encoding="utf-8"?>
 <p:sld xmlns:a="http://schemas.openxmlformats.org/drawingml/2006/main" xmlns:r="http://schemas.openxmlformats.org/officeDocument/2006/relationships" xmlns:p="http://schemas.openxmlformats.org/presentationml/2006/main">
   <p:cSld>
     <p:spTree>

</xml_diff>